<commit_message>
Reframe Model 3 as alternative age-stratification specification across manuscript, slides, and build_socr docstring.
</commit_message>
<xml_diff>
--- a/MMA_rescue_slides.pptx
+++ b/MMA_rescue_slides.pptx
@@ -5171,7 +5171,7 @@
                 </a:solidFill>
                 <a:latin typeface="Helvetica"/>
               </a:rPr>
-              <a:t>• Model 3 — co-author derivation (age &gt;85, plt, antiplatelet)</a:t>
+              <a:t>• Model 3 — alternative age-stratification (age &gt;85, plt, antiplatelet)</a:t>
             </a:r>
           </a:p>
           <a:p>
@@ -9040,7 +9040,7 @@
                 </a:solidFill>
                 <a:latin typeface="Helvetica"/>
               </a:rPr>
-              <a:t>• Model 3 (co-author, 5 pts)  AUC 0.70</a:t>
+              <a:t>• Model 3 (age cutoff &gt;85, 5 pts)  AUC 0.70</a:t>
             </a:r>
           </a:p>
           <a:p>

</xml_diff>